<commit_message>
Rebuild Weak10 course catalog lesson
</commit_message>
<xml_diff>
--- a/Weak10/Lesson.pptx
+++ b/Weak10/Lesson.pptx
@@ -2,116 +2,21 @@
 <file path=ppt/presentation.xml><?xml version="1.0" encoding="utf-8"?>
 <p:presentation xmlns:p="http://schemas.openxmlformats.org/presentationml/2006/main">
   <p:sldMasterIdLst>
-    <p:sldMasterId xmlns:r="http://schemas.openxmlformats.org/officeDocument/2006/relationships" id="2147483648" r:id="R103fe9cdd3f3437c"/>
+    <p:sldMasterId xmlns:r="http://schemas.openxmlformats.org/officeDocument/2006/relationships" id="2147483648" r:id="R25d897e3f27144ab"/>
   </p:sldMasterIdLst>
   <p:notesMasterIdLst>
-    <p:notesMasterId xmlns:r="http://schemas.openxmlformats.org/officeDocument/2006/relationships" r:id="Rbf48313aff264a8b"/>
+    <p:notesMasterId xmlns:r="http://schemas.openxmlformats.org/officeDocument/2006/relationships" r:id="R000025fa0b2f4f00"/>
   </p:notesMasterIdLst>
   <p:sldIdLst>
-    <p:sldId xmlns:r="http://schemas.openxmlformats.org/officeDocument/2006/relationships" id="256" r:id="R203d366995894fb9"/>
-    <p:sldId xmlns:r="http://schemas.openxmlformats.org/officeDocument/2006/relationships" id="257" r:id="R8fe45575e68a4a1a"/>
-    <p:sldId xmlns:r="http://schemas.openxmlformats.org/officeDocument/2006/relationships" id="258" r:id="R9421ad7276eb4176"/>
-    <p:sldId xmlns:r="http://schemas.openxmlformats.org/officeDocument/2006/relationships" id="259" r:id="R449ceb1cc1c54b20"/>
-    <p:sldId xmlns:r="http://schemas.openxmlformats.org/officeDocument/2006/relationships" id="260" r:id="R70f3a3ffce78415f"/>
-    <p:sldId xmlns:r="http://schemas.openxmlformats.org/officeDocument/2006/relationships" id="261" r:id="Re3e5208f8971466d"/>
+    <p:sldId xmlns:r="http://schemas.openxmlformats.org/officeDocument/2006/relationships" id="256" r:id="Rff80959335e247cd"/>
+    <p:sldId xmlns:r="http://schemas.openxmlformats.org/officeDocument/2006/relationships" id="257" r:id="R2a68db5d112d45e4"/>
+    <p:sldId xmlns:r="http://schemas.openxmlformats.org/officeDocument/2006/relationships" id="258" r:id="R4f6affee7c6e4491"/>
+    <p:sldId xmlns:r="http://schemas.openxmlformats.org/officeDocument/2006/relationships" id="259" r:id="R6b5b50a706ff45b3"/>
+    <p:sldId xmlns:r="http://schemas.openxmlformats.org/officeDocument/2006/relationships" id="260" r:id="R1ccb290f213a42b6"/>
+    <p:sldId xmlns:r="http://schemas.openxmlformats.org/officeDocument/2006/relationships" id="261" r:id="R9e462c35048a45fb"/>
   </p:sldIdLst>
   <p:sldSz cx="12192000" cy="6858000"/>
   <p:notesSz cx="6858000" cy="9144000"/>
-  <p:defaultTextStyle>
-    <a:defPPr xmlns:a="http://schemas.openxmlformats.org/drawingml/2006/main">
-      <a:defRPr lang="en-US"/>
-    </a:defPPr>
-    <a:lvl1pPr xmlns:a="http://schemas.openxmlformats.org/drawingml/2006/main" marL="0" indent="0" algn="l" defTabSz="914400">
-      <a:defRPr sz="1800" kern="1200">
-        <a:solidFill>
-          <a:schemeClr val="tx1"/>
-        </a:solidFill>
-        <a:latin typeface="+mn-lt"/>
-        <a:ea typeface="+mn-ea"/>
-        <a:cs typeface="+mn-cs"/>
-      </a:defRPr>
-    </a:lvl1pPr>
-    <a:lvl2pPr xmlns:a="http://schemas.openxmlformats.org/drawingml/2006/main" marL="457200" indent="0" algn="l" defTabSz="914400">
-      <a:defRPr sz="1800" kern="1200">
-        <a:solidFill>
-          <a:schemeClr val="tx1"/>
-        </a:solidFill>
-        <a:latin typeface="+mn-lt"/>
-        <a:ea typeface="+mn-ea"/>
-        <a:cs typeface="+mn-cs"/>
-      </a:defRPr>
-    </a:lvl2pPr>
-    <a:lvl3pPr xmlns:a="http://schemas.openxmlformats.org/drawingml/2006/main" marL="914400" indent="0" algn="l" defTabSz="914400">
-      <a:defRPr sz="1800" kern="1200">
-        <a:solidFill>
-          <a:schemeClr val="tx1"/>
-        </a:solidFill>
-        <a:latin typeface="+mn-lt"/>
-        <a:ea typeface="+mn-ea"/>
-        <a:cs typeface="+mn-cs"/>
-      </a:defRPr>
-    </a:lvl3pPr>
-    <a:lvl4pPr xmlns:a="http://schemas.openxmlformats.org/drawingml/2006/main" marL="1371600" indent="0" algn="l" defTabSz="914400">
-      <a:defRPr sz="1800" kern="1200">
-        <a:solidFill>
-          <a:schemeClr val="tx1"/>
-        </a:solidFill>
-        <a:latin typeface="+mn-lt"/>
-        <a:ea typeface="+mn-ea"/>
-        <a:cs typeface="+mn-cs"/>
-      </a:defRPr>
-    </a:lvl4pPr>
-    <a:lvl5pPr xmlns:a="http://schemas.openxmlformats.org/drawingml/2006/main" marL="1828800" indent="0" algn="l" defTabSz="914400">
-      <a:defRPr sz="1800" kern="1200">
-        <a:solidFill>
-          <a:schemeClr val="tx1"/>
-        </a:solidFill>
-        <a:latin typeface="+mn-lt"/>
-        <a:ea typeface="+mn-ea"/>
-        <a:cs typeface="+mn-cs"/>
-      </a:defRPr>
-    </a:lvl5pPr>
-    <a:lvl6pPr xmlns:a="http://schemas.openxmlformats.org/drawingml/2006/main" marL="2286000" indent="0" algn="l" defTabSz="914400">
-      <a:defRPr sz="1800" kern="1200">
-        <a:solidFill>
-          <a:schemeClr val="tx1"/>
-        </a:solidFill>
-        <a:latin typeface="+mn-lt"/>
-        <a:ea typeface="+mn-ea"/>
-        <a:cs typeface="+mn-cs"/>
-      </a:defRPr>
-    </a:lvl6pPr>
-    <a:lvl7pPr xmlns:a="http://schemas.openxmlformats.org/drawingml/2006/main" marL="2743200" indent="0" algn="l" defTabSz="914400">
-      <a:defRPr sz="1800" kern="1200">
-        <a:solidFill>
-          <a:schemeClr val="tx1"/>
-        </a:solidFill>
-        <a:latin typeface="+mn-lt"/>
-        <a:ea typeface="+mn-ea"/>
-        <a:cs typeface="+mn-cs"/>
-      </a:defRPr>
-    </a:lvl7pPr>
-    <a:lvl8pPr xmlns:a="http://schemas.openxmlformats.org/drawingml/2006/main" marL="3200400" indent="0" algn="l" defTabSz="914400">
-      <a:defRPr sz="1800" kern="1200">
-        <a:solidFill>
-          <a:schemeClr val="tx1"/>
-        </a:solidFill>
-        <a:latin typeface="+mn-lt"/>
-        <a:ea typeface="+mn-ea"/>
-        <a:cs typeface="+mn-cs"/>
-      </a:defRPr>
-    </a:lvl8pPr>
-    <a:lvl9pPr xmlns:a="http://schemas.openxmlformats.org/drawingml/2006/main" marL="3657600" indent="0" algn="l" defTabSz="914400">
-      <a:defRPr sz="1800" kern="1200">
-        <a:solidFill>
-          <a:schemeClr val="tx1"/>
-        </a:solidFill>
-        <a:latin typeface="+mn-lt"/>
-        <a:ea typeface="+mn-ea"/>
-        <a:cs typeface="+mn-cs"/>
-      </a:defRPr>
-    </a:lvl9pPr>
-  </p:defaultTextStyle>
 </p:presentation>
 </file>
 
@@ -540,7 +445,21 @@
         <p:txBody>
           <a:bodyPr xmlns:a="http://schemas.openxmlformats.org/drawingml/2006/main"/>
           <a:lstStyle xmlns:a="http://schemas.openxmlformats.org/drawingml/2006/main"/>
-          <a:p xmlns:a="http://schemas.openxmlformats.org/drawingml/2006/main"/>
+          <a:p xmlns:a="http://schemas.openxmlformats.org/drawingml/2006/main">
+            <a:r>
+              <a:t>[Sources]</a:t>
+            </a:r>
+          </a:p>
+          <a:p xmlns:a="http://schemas.openxmlformats.org/drawingml/2006/main">
+            <a:r>
+              <a:t>- User-supplied local examples: test/course-catalog-service-9, test/course-catalog-service-10, test/course-catalog-service-11.</a:t>
+            </a:r>
+          </a:p>
+          <a:p xmlns:a="http://schemas.openxmlformats.org/drawingml/2006/main">
+            <a:r>
+              <a:t>- Implemented lesson: Weak10 source code and README.</a:t>
+            </a:r>
+          </a:p>
         </p:txBody>
       </p:sp>
       <p:sp>
@@ -606,7 +525,21 @@
         <p:txBody>
           <a:bodyPr xmlns:a="http://schemas.openxmlformats.org/drawingml/2006/main"/>
           <a:lstStyle xmlns:a="http://schemas.openxmlformats.org/drawingml/2006/main"/>
-          <a:p xmlns:a="http://schemas.openxmlformats.org/drawingml/2006/main"/>
+          <a:p xmlns:a="http://schemas.openxmlformats.org/drawingml/2006/main">
+            <a:r>
+              <a:t>[Sources]</a:t>
+            </a:r>
+          </a:p>
+          <a:p xmlns:a="http://schemas.openxmlformats.org/drawingml/2006/main">
+            <a:r>
+              <a:t>- User-supplied local examples: test/course-catalog-service-9, test/course-catalog-service-10, test/course-catalog-service-11.</a:t>
+            </a:r>
+          </a:p>
+          <a:p xmlns:a="http://schemas.openxmlformats.org/drawingml/2006/main">
+            <a:r>
+              <a:t>- Implemented lesson: Weak10 source code and README.</a:t>
+            </a:r>
+          </a:p>
         </p:txBody>
       </p:sp>
       <p:sp>
@@ -672,7 +605,21 @@
         <p:txBody>
           <a:bodyPr xmlns:a="http://schemas.openxmlformats.org/drawingml/2006/main"/>
           <a:lstStyle xmlns:a="http://schemas.openxmlformats.org/drawingml/2006/main"/>
-          <a:p xmlns:a="http://schemas.openxmlformats.org/drawingml/2006/main"/>
+          <a:p xmlns:a="http://schemas.openxmlformats.org/drawingml/2006/main">
+            <a:r>
+              <a:t>[Sources]</a:t>
+            </a:r>
+          </a:p>
+          <a:p xmlns:a="http://schemas.openxmlformats.org/drawingml/2006/main">
+            <a:r>
+              <a:t>- User-supplied local examples: test/course-catalog-service-9, test/course-catalog-service-10, test/course-catalog-service-11.</a:t>
+            </a:r>
+          </a:p>
+          <a:p xmlns:a="http://schemas.openxmlformats.org/drawingml/2006/main">
+            <a:r>
+              <a:t>- Implemented lesson: Weak10 source code and README.</a:t>
+            </a:r>
+          </a:p>
         </p:txBody>
       </p:sp>
       <p:sp>
@@ -738,7 +685,21 @@
         <p:txBody>
           <a:bodyPr xmlns:a="http://schemas.openxmlformats.org/drawingml/2006/main"/>
           <a:lstStyle xmlns:a="http://schemas.openxmlformats.org/drawingml/2006/main"/>
-          <a:p xmlns:a="http://schemas.openxmlformats.org/drawingml/2006/main"/>
+          <a:p xmlns:a="http://schemas.openxmlformats.org/drawingml/2006/main">
+            <a:r>
+              <a:t>[Sources]</a:t>
+            </a:r>
+          </a:p>
+          <a:p xmlns:a="http://schemas.openxmlformats.org/drawingml/2006/main">
+            <a:r>
+              <a:t>- User-supplied local examples: test/course-catalog-service-9, test/course-catalog-service-10, test/course-catalog-service-11.</a:t>
+            </a:r>
+          </a:p>
+          <a:p xmlns:a="http://schemas.openxmlformats.org/drawingml/2006/main">
+            <a:r>
+              <a:t>- Implemented lesson: Weak10 source code and README.</a:t>
+            </a:r>
+          </a:p>
         </p:txBody>
       </p:sp>
       <p:sp>
@@ -804,7 +765,21 @@
         <p:txBody>
           <a:bodyPr xmlns:a="http://schemas.openxmlformats.org/drawingml/2006/main"/>
           <a:lstStyle xmlns:a="http://schemas.openxmlformats.org/drawingml/2006/main"/>
-          <a:p xmlns:a="http://schemas.openxmlformats.org/drawingml/2006/main"/>
+          <a:p xmlns:a="http://schemas.openxmlformats.org/drawingml/2006/main">
+            <a:r>
+              <a:t>[Sources]</a:t>
+            </a:r>
+          </a:p>
+          <a:p xmlns:a="http://schemas.openxmlformats.org/drawingml/2006/main">
+            <a:r>
+              <a:t>- User-supplied local examples: test/course-catalog-service-9, test/course-catalog-service-10, test/course-catalog-service-11.</a:t>
+            </a:r>
+          </a:p>
+          <a:p xmlns:a="http://schemas.openxmlformats.org/drawingml/2006/main">
+            <a:r>
+              <a:t>- Implemented lesson: Weak10 source code and README.</a:t>
+            </a:r>
+          </a:p>
         </p:txBody>
       </p:sp>
       <p:sp>
@@ -870,7 +845,21 @@
         <p:txBody>
           <a:bodyPr xmlns:a="http://schemas.openxmlformats.org/drawingml/2006/main"/>
           <a:lstStyle xmlns:a="http://schemas.openxmlformats.org/drawingml/2006/main"/>
-          <a:p xmlns:a="http://schemas.openxmlformats.org/drawingml/2006/main"/>
+          <a:p xmlns:a="http://schemas.openxmlformats.org/drawingml/2006/main">
+            <a:r>
+              <a:t>[Sources]</a:t>
+            </a:r>
+          </a:p>
+          <a:p xmlns:a="http://schemas.openxmlformats.org/drawingml/2006/main">
+            <a:r>
+              <a:t>- User-supplied local examples: test/course-catalog-service-9, test/course-catalog-service-10, test/course-catalog-service-11.</a:t>
+            </a:r>
+          </a:p>
+          <a:p xmlns:a="http://schemas.openxmlformats.org/drawingml/2006/main">
+            <a:r>
+              <a:t>- Implemented lesson: Weak10 source code and README.</a:t>
+            </a:r>
+          </a:p>
         </p:txBody>
       </p:sp>
       <p:sp>
@@ -936,7 +925,7 @@
   </p:cSld>
   <p:clrMap bg1="lt1" tx1="dk1" bg2="lt2" tx2="dk2" accent1="accent1" accent2="accent2" accent3="accent3" accent4="accent4" accent5="accent5" accent6="accent6" hlink="hlink" folHlink="folHlink"/>
   <p:sldLayoutIdLst>
-    <p:sldLayoutId xmlns:r="http://schemas.openxmlformats.org/officeDocument/2006/relationships" id="2147483649" r:id="R37f7c2284bb34eb7"/>
+    <p:sldLayoutId xmlns:r="http://schemas.openxmlformats.org/officeDocument/2006/relationships" id="2147483649" r:id="R7487a02bef714763"/>
   </p:sldLayoutIdLst>
   <p:txStyles>
     <p:titleStyle>
@@ -1512,6 +1501,7 @@
           <a:lstStyle xmlns:a="http://schemas.openxmlformats.org/drawingml/2006/main"/>
           <a:p xmlns:a="http://schemas.openxmlformats.org/drawingml/2006/main">
             <a:pPr algn="l">
+              <a:buNone/>
               <a:defRPr sz="1800" b="1">
                 <a:solidFill>
                   <a:srgbClr val="000000"/>
@@ -1557,6 +1547,7 @@
           <a:lstStyle xmlns:a="http://schemas.openxmlformats.org/drawingml/2006/main"/>
           <a:p xmlns:a="http://schemas.openxmlformats.org/drawingml/2006/main">
             <a:pPr algn="r">
+              <a:buNone/>
               <a:defRPr sz="1800" b="0">
                 <a:solidFill>
                   <a:srgbClr val="4B5563"/>
@@ -1629,6 +1620,7 @@
           <a:lstStyle xmlns:a="http://schemas.openxmlformats.org/drawingml/2006/main"/>
           <a:p xmlns:a="http://schemas.openxmlformats.org/drawingml/2006/main">
             <a:pPr algn="l">
+              <a:buNone/>
               <a:defRPr sz="4200" b="1">
                 <a:solidFill>
                   <a:srgbClr val="000000"/>
@@ -1639,7 +1631,7 @@
               </a:defRPr>
             </a:pPr>
             <a:r>
-              <a:t>Тестирование базы и конкурентности</a:t>
+              <a:t>Course Catalog: JPA и validation</a:t>
             </a:r>
           </a:p>
         </p:txBody>
@@ -1674,6 +1666,7 @@
           <a:lstStyle xmlns:a="http://schemas.openxmlformats.org/drawingml/2006/main"/>
           <a:p xmlns:a="http://schemas.openxmlformats.org/drawingml/2006/main">
             <a:pPr algn="l">
+              <a:buNone/>
               <a:defRPr sz="1800" b="0">
                 <a:solidFill>
                   <a:srgbClr val="4B5563"/>
@@ -1684,7 +1677,7 @@
               </a:defRPr>
             </a:pPr>
             <a:r>
-              <a:t>Проверять гарантии настоящего PostgreSQL, а не поведение mock или совместимой in-memory базы.</a:t>
+              <a:t>Собрать вертикальный срез: DTO, service rule, JPA-связь, внешний ключ и стабильный HTTP-контракт.</a:t>
             </a:r>
           </a:p>
         </p:txBody>
@@ -1719,6 +1712,7 @@
           <a:lstStyle xmlns:a="http://schemas.openxmlformats.org/drawingml/2006/main"/>
           <a:p xmlns:a="http://schemas.openxmlformats.org/drawingml/2006/main">
             <a:pPr algn="l">
+              <a:buNone/>
               <a:defRPr sz="1050" b="0">
                 <a:solidFill>
                   <a:srgbClr val="4B5563"/>
@@ -1729,7 +1723,7 @@
               </a:defRPr>
             </a:pPr>
             <a:r>
-              <a:t>Материал урока и лабораторная работа</a:t>
+              <a:t>По мотивам course-catalog-service-9…11</a:t>
             </a:r>
           </a:p>
         </p:txBody>
@@ -1793,6 +1787,7 @@
           <a:lstStyle xmlns:a="http://schemas.openxmlformats.org/drawingml/2006/main"/>
           <a:p xmlns:a="http://schemas.openxmlformats.org/drawingml/2006/main">
             <a:pPr algn="l">
+              <a:buNone/>
               <a:defRPr sz="2850" b="1">
                 <a:solidFill>
                   <a:srgbClr val="000000"/>
@@ -1803,7 +1798,7 @@
               </a:defRPr>
             </a:pPr>
             <a:r>
-              <a:t>Три опоры урока</a:t>
+              <a:t>Три границы защищают один инвариант</a:t>
             </a:r>
           </a:p>
         </p:txBody>
@@ -1838,6 +1833,7 @@
           <a:lstStyle xmlns:a="http://schemas.openxmlformats.org/drawingml/2006/main"/>
           <a:p xmlns:a="http://schemas.openxmlformats.org/drawingml/2006/main">
             <a:pPr algn="l">
+              <a:buNone/>
               <a:defRPr sz="1500" b="0">
                 <a:solidFill>
                   <a:srgbClr val="4B5563"/>
@@ -1848,7 +1844,7 @@
               </a:defRPr>
             </a:pPr>
             <a:r>
-              <a:t>Хороший тест управляет конфликтом, ломается без защиты и проверяет бизнес-инвариант.</a:t>
+              <a:t>Курс существует только с валидными полями и реальным преподавателем.</a:t>
             </a:r>
           </a:p>
         </p:txBody>
@@ -1916,6 +1912,7 @@
           <a:lstStyle xmlns:a="http://schemas.openxmlformats.org/drawingml/2006/main"/>
           <a:p xmlns:a="http://schemas.openxmlformats.org/drawingml/2006/main">
             <a:pPr algn="l">
+              <a:buNone/>
               <a:defRPr sz="1800" b="1">
                 <a:solidFill>
                   <a:srgbClr val="000000"/>
@@ -1926,7 +1923,7 @@
               </a:defRPr>
             </a:pPr>
             <a:r>
-              <a:t>Real database</a:t>
+              <a:t>DTO</a:t>
             </a:r>
           </a:p>
         </p:txBody>
@@ -1961,6 +1958,7 @@
           <a:lstStyle xmlns:a="http://schemas.openxmlformats.org/drawingml/2006/main"/>
           <a:p xmlns:a="http://schemas.openxmlformats.org/drawingml/2006/main">
             <a:pPr algn="l">
+              <a:buNone/>
               <a:defRPr sz="1425" b="0">
                 <a:solidFill>
                   <a:srgbClr val="4B5563"/>
@@ -1971,7 +1969,7 @@
               </a:defRPr>
             </a:pPr>
             <a:r>
-              <a:t>Testcontainers поднимает PostgreSQL нужной версии, Flyway и настоящие constraints.</a:t>
+              <a:t>@Valid проверяет форму JSON: непустые name/category и положительный instructorId.</a:t>
             </a:r>
           </a:p>
         </p:txBody>
@@ -2039,6 +2037,7 @@
           <a:lstStyle xmlns:a="http://schemas.openxmlformats.org/drawingml/2006/main"/>
           <a:p xmlns:a="http://schemas.openxmlformats.org/drawingml/2006/main">
             <a:pPr algn="l">
+              <a:buNone/>
               <a:defRPr sz="1800" b="1">
                 <a:solidFill>
                   <a:srgbClr val="000000"/>
@@ -2049,7 +2048,7 @@
               </a:defRPr>
             </a:pPr>
             <a:r>
-              <a:t>Deterministic race</a:t>
+              <a:t>Service</a:t>
             </a:r>
           </a:p>
         </p:txBody>
@@ -2084,6 +2083,7 @@
           <a:lstStyle xmlns:a="http://schemas.openxmlformats.org/drawingml/2006/main"/>
           <a:p xmlns:a="http://schemas.openxmlformats.org/drawingml/2006/main">
             <a:pPr algn="l">
+              <a:buNone/>
               <a:defRPr sz="1425" b="0">
                 <a:solidFill>
                   <a:srgbClr val="4B5563"/>
@@ -2094,7 +2094,7 @@
               </a:defRPr>
             </a:pPr>
             <a:r>
-              <a:t>Barriers/latches синхронизируют транзакции в точке конфликта вместо случайного timing.</a:t>
+              <a:t>Бизнес-правило требует существующего Instructor до сохранения Course.</a:t>
             </a:r>
           </a:p>
         </p:txBody>
@@ -2162,6 +2162,7 @@
           <a:lstStyle xmlns:a="http://schemas.openxmlformats.org/drawingml/2006/main"/>
           <a:p xmlns:a="http://schemas.openxmlformats.org/drawingml/2006/main">
             <a:pPr algn="l">
+              <a:buNone/>
               <a:defRPr sz="1800" b="1">
                 <a:solidFill>
                   <a:srgbClr val="000000"/>
@@ -2172,7 +2173,7 @@
               </a:defRPr>
             </a:pPr>
             <a:r>
-              <a:t>Invariant</a:t>
+              <a:t>PostgreSQL</a:t>
             </a:r>
           </a:p>
         </p:txBody>
@@ -2207,6 +2208,7 @@
           <a:lstStyle xmlns:a="http://schemas.openxmlformats.org/drawingml/2006/main"/>
           <a:p xmlns:a="http://schemas.openxmlformats.org/drawingml/2006/main">
             <a:pPr algn="l">
+              <a:buNone/>
               <a:defRPr sz="1425" b="0">
                 <a:solidFill>
                   <a:srgbClr val="4B5563"/>
@@ -2217,7 +2219,7 @@
               </a:defRPr>
             </a:pPr>
             <a:r>
-              <a:t>Общая сумма, отсутствие дубля и rollback важнее проверки внутреннего вызова mock.</a:t>
+              <a:t>NOT NULL, CHECK и FOREIGN KEY защищают данные при любом пути записи.</a:t>
             </a:r>
           </a:p>
         </p:txBody>
@@ -2252,6 +2254,7 @@
           <a:lstStyle xmlns:a="http://schemas.openxmlformats.org/drawingml/2006/main"/>
           <a:p xmlns:a="http://schemas.openxmlformats.org/drawingml/2006/main">
             <a:pPr algn="r">
+              <a:buNone/>
               <a:defRPr sz="975" b="0">
                 <a:solidFill>
                   <a:srgbClr val="4B5563"/>
@@ -2326,6 +2329,7 @@
           <a:lstStyle xmlns:a="http://schemas.openxmlformats.org/drawingml/2006/main"/>
           <a:p xmlns:a="http://schemas.openxmlformats.org/drawingml/2006/main">
             <a:pPr algn="l">
+              <a:buNone/>
               <a:defRPr sz="2850" b="1">
                 <a:solidFill>
                   <a:srgbClr val="000000"/>
@@ -2336,7 +2340,7 @@
               </a:defRPr>
             </a:pPr>
             <a:r>
-              <a:t>Тест должен краснеть при удалении механизма защиты</a:t>
+              <a:t>Связь надёжна, когда границы разделены</a:t>
             </a:r>
           </a:p>
         </p:txBody>
@@ -2404,6 +2408,7 @@
           <a:lstStyle xmlns:a="http://schemas.openxmlformats.org/drawingml/2006/main"/>
           <a:p xmlns:a="http://schemas.openxmlformats.org/drawingml/2006/main">
             <a:pPr algn="l">
+              <a:buNone/>
               <a:defRPr sz="1650" b="1">
                 <a:solidFill>
                   <a:srgbClr val="000000"/>
@@ -2414,7 +2419,7 @@
               </a:defRPr>
             </a:pPr>
             <a:r>
-              <a:t>Test pyramid</a:t>
+              <a:t>DTO ≠ entity</a:t>
             </a:r>
           </a:p>
         </p:txBody>
@@ -2449,6 +2454,7 @@
           <a:lstStyle xmlns:a="http://schemas.openxmlformats.org/drawingml/2006/main"/>
           <a:p xmlns:a="http://schemas.openxmlformats.org/drawingml/2006/main">
             <a:pPr algn="l">
+              <a:buNone/>
               <a:defRPr sz="1350" b="0">
                 <a:solidFill>
                   <a:srgbClr val="4B5563"/>
@@ -2459,7 +2465,7 @@
               </a:defRPr>
             </a:pPr>
             <a:r>
-              <a:t>Unit быстры, slice проверяют слой, integration связывают БД, end-to-end проверяют поток.</a:t>
+              <a:t>Request/response не зависят от proxy, lazy loading и структуры таблиц.</a:t>
             </a:r>
           </a:p>
         </p:txBody>
@@ -2527,6 +2533,7 @@
           <a:lstStyle xmlns:a="http://schemas.openxmlformats.org/drawingml/2006/main"/>
           <a:p xmlns:a="http://schemas.openxmlformats.org/drawingml/2006/main">
             <a:pPr algn="l">
+              <a:buNone/>
               <a:defRPr sz="1650" b="1">
                 <a:solidFill>
                   <a:srgbClr val="000000"/>
@@ -2537,7 +2544,7 @@
               </a:defRPr>
             </a:pPr>
             <a:r>
-              <a:t>Migration test</a:t>
+              <a:t>Owning side</a:t>
             </a:r>
           </a:p>
         </p:txBody>
@@ -2572,6 +2579,7 @@
           <a:lstStyle xmlns:a="http://schemas.openxmlformats.org/drawingml/2006/main"/>
           <a:p xmlns:a="http://schemas.openxmlformats.org/drawingml/2006/main">
             <a:pPr algn="l">
+              <a:buNone/>
               <a:defRPr sz="1350" b="0">
                 <a:solidFill>
                   <a:srgbClr val="4B5563"/>
@@ -2582,7 +2590,7 @@
               </a:defRPr>
             </a:pPr>
             <a:r>
-              <a:t>Чистая база проходит все migrations; существующее состояние проверяет backward compatibility.</a:t>
+              <a:t>Course.instructor хранит instructor_id; mappedBy описывает обратную сторону.</a:t>
             </a:r>
           </a:p>
         </p:txBody>
@@ -2650,6 +2658,7 @@
           <a:lstStyle xmlns:a="http://schemas.openxmlformats.org/drawingml/2006/main"/>
           <a:p xmlns:a="http://schemas.openxmlformats.org/drawingml/2006/main">
             <a:pPr algn="l">
+              <a:buNone/>
               <a:defRPr sz="1650" b="1">
                 <a:solidFill>
                   <a:srgbClr val="000000"/>
@@ -2660,7 +2669,7 @@
               </a:defRPr>
             </a:pPr>
             <a:r>
-              <a:t>Concurrency control</a:t>
+              <a:t>Validation</a:t>
             </a:r>
           </a:p>
         </p:txBody>
@@ -2695,6 +2704,7 @@
           <a:lstStyle xmlns:a="http://schemas.openxmlformats.org/drawingml/2006/main"/>
           <a:p xmlns:a="http://schemas.openxmlformats.org/drawingml/2006/main">
             <a:pPr algn="l">
+              <a:buNone/>
               <a:defRPr sz="1350" b="0">
                 <a:solidFill>
                   <a:srgbClr val="4B5563"/>
@@ -2705,7 +2715,7 @@
               </a:defRPr>
             </a:pPr>
             <a:r>
-              <a:t>Latch останавливает участников после read/lock и освобождает их одновременно.</a:t>
+              <a:t>@Valid проверяет DTO, service — существование Instructor, FK — целостность.</a:t>
             </a:r>
           </a:p>
         </p:txBody>
@@ -2773,6 +2783,7 @@
           <a:lstStyle xmlns:a="http://schemas.openxmlformats.org/drawingml/2006/main"/>
           <a:p xmlns:a="http://schemas.openxmlformats.org/drawingml/2006/main">
             <a:pPr algn="l">
+              <a:buNone/>
               <a:defRPr sz="1650" b="1">
                 <a:solidFill>
                   <a:srgbClr val="000000"/>
@@ -2783,7 +2794,7 @@
               </a:defRPr>
             </a:pPr>
             <a:r>
-              <a:t>Mutation check</a:t>
+              <a:t>Error contract</a:t>
             </a:r>
           </a:p>
         </p:txBody>
@@ -2818,6 +2829,7 @@
           <a:lstStyle xmlns:a="http://schemas.openxmlformats.org/drawingml/2006/main"/>
           <a:p xmlns:a="http://schemas.openxmlformats.org/drawingml/2006/main">
             <a:pPr algn="l">
+              <a:buNone/>
               <a:defRPr sz="1350" b="0">
                 <a:solidFill>
                   <a:srgbClr val="4B5563"/>
@@ -2828,7 +2840,7 @@
               </a:defRPr>
             </a:pPr>
             <a:r>
-              <a:t>Удаление UNIQUE, CHECK или atomic predicate должно делать соответствующий тест красным.</a:t>
+              <a:t>status + code + details + requestId стабильнее сырого текста exception.</a:t>
             </a:r>
           </a:p>
         </p:txBody>
@@ -2863,6 +2875,7 @@
           <a:lstStyle xmlns:a="http://schemas.openxmlformats.org/drawingml/2006/main"/>
           <a:p xmlns:a="http://schemas.openxmlformats.org/drawingml/2006/main">
             <a:pPr algn="r">
+              <a:buNone/>
               <a:defRPr sz="975" b="0">
                 <a:solidFill>
                   <a:srgbClr val="4B5563"/>
@@ -2937,6 +2950,7 @@
           <a:lstStyle xmlns:a="http://schemas.openxmlformats.org/drawingml/2006/main"/>
           <a:p xmlns:a="http://schemas.openxmlformats.org/drawingml/2006/main">
             <a:pPr algn="l">
+              <a:buNone/>
               <a:defRPr sz="2850" b="1">
                 <a:solidFill>
                   <a:srgbClr val="000000"/>
@@ -2947,7 +2961,7 @@
               </a:defRPr>
             </a:pPr>
             <a:r>
-              <a:t>Конкурентный тест сначала создаёт конфликт</a:t>
+              <a:t>Один POST проходит все уровни защиты</a:t>
             </a:r>
           </a:p>
         </p:txBody>
@@ -2982,6 +2996,7 @@
           <a:lstStyle xmlns:a="http://schemas.openxmlformats.org/drawingml/2006/main"/>
           <a:p xmlns:a="http://schemas.openxmlformats.org/drawingml/2006/main">
             <a:pPr algn="l">
+              <a:buNone/>
               <a:defRPr sz="1500" b="0">
                 <a:solidFill>
                   <a:srgbClr val="4B5563"/>
@@ -2992,7 +3007,7 @@
               </a:defRPr>
             </a:pPr>
             <a:r>
-              <a:t>Если race зависит от удачи scheduler, тест не доказывает гарантию.</a:t>
+              <a:t>Каждый следующий слой проверяет то, чего не может доказать предыдущий.</a:t>
             </a:r>
           </a:p>
         </p:txBody>
@@ -3081,6 +3096,7 @@
           <a:lstStyle xmlns:a="http://schemas.openxmlformats.org/drawingml/2006/main"/>
           <a:p xmlns:a="http://schemas.openxmlformats.org/drawingml/2006/main">
             <a:pPr algn="l">
+              <a:buNone/>
               <a:defRPr sz="1350" b="1">
                 <a:solidFill>
                   <a:srgbClr val="3D8DFF"/>
@@ -3091,7 +3107,7 @@
               </a:defRPr>
             </a:pPr>
             <a:r>
-              <a:t>01 / ARRANGE</a:t>
+              <a:t>01 / VALIDATE</a:t>
             </a:r>
           </a:p>
         </p:txBody>
@@ -3126,6 +3142,7 @@
           <a:lstStyle xmlns:a="http://schemas.openxmlformats.org/drawingml/2006/main"/>
           <a:p xmlns:a="http://schemas.openxmlformats.org/drawingml/2006/main">
             <a:pPr algn="l">
+              <a:buNone/>
               <a:defRPr sz="1725" b="1">
                 <a:solidFill>
                   <a:srgbClr val="000000"/>
@@ -3136,7 +3153,7 @@
               </a:defRPr>
             </a:pPr>
             <a:r>
-              <a:t>Поднять PostgreSQL</a:t>
+              <a:t>Проверить DTO</a:t>
             </a:r>
           </a:p>
         </p:txBody>
@@ -3171,6 +3188,7 @@
           <a:lstStyle xmlns:a="http://schemas.openxmlformats.org/drawingml/2006/main"/>
           <a:p xmlns:a="http://schemas.openxmlformats.org/drawingml/2006/main">
             <a:pPr algn="l">
+              <a:buNone/>
               <a:defRPr sz="1350" b="0">
                 <a:solidFill>
                   <a:srgbClr val="4B5563"/>
@@ -3181,7 +3199,7 @@
               </a:defRPr>
             </a:pPr>
             <a:r>
-              <a:t>Запустить container, применить Flyway и подготовить invariant state.</a:t>
+              <a:t>Controller активирует @Valid и отклоняет пустые поля до service.</a:t>
             </a:r>
           </a:p>
         </p:txBody>
@@ -3243,6 +3261,7 @@
           <a:lstStyle xmlns:a="http://schemas.openxmlformats.org/drawingml/2006/main"/>
           <a:p xmlns:a="http://schemas.openxmlformats.org/drawingml/2006/main">
             <a:pPr algn="l">
+              <a:buNone/>
               <a:defRPr sz="1350" b="1">
                 <a:solidFill>
                   <a:srgbClr val="3D8DFF"/>
@@ -3253,7 +3272,7 @@
               </a:defRPr>
             </a:pPr>
             <a:r>
-              <a:t>02 / COLLIDE</a:t>
+              <a:t>02 / RESOLVE</a:t>
             </a:r>
           </a:p>
         </p:txBody>
@@ -3288,6 +3307,7 @@
           <a:lstStyle xmlns:a="http://schemas.openxmlformats.org/drawingml/2006/main"/>
           <a:p xmlns:a="http://schemas.openxmlformats.org/drawingml/2006/main">
             <a:pPr algn="l">
+              <a:buNone/>
               <a:defRPr sz="1725" b="1">
                 <a:solidFill>
                   <a:srgbClr val="000000"/>
@@ -3298,7 +3318,7 @@
               </a:defRPr>
             </a:pPr>
             <a:r>
-              <a:t>Синхронизировать T</a:t>
+              <a:t>Найти Instructor</a:t>
             </a:r>
           </a:p>
         </p:txBody>
@@ -3333,6 +3353,7 @@
           <a:lstStyle xmlns:a="http://schemas.openxmlformats.org/drawingml/2006/main"/>
           <a:p xmlns:a="http://schemas.openxmlformats.org/drawingml/2006/main">
             <a:pPr algn="l">
+              <a:buNone/>
               <a:defRPr sz="1350" b="0">
                 <a:solidFill>
                   <a:srgbClr val="4B5563"/>
@@ -3343,7 +3364,7 @@
               </a:defRPr>
             </a:pPr>
             <a:r>
-              <a:t>Довести competitors до barrier и одновременно разрешить запись.</a:t>
+              <a:t>Service загружает преподавателя или возвращает INSTRUCTOR_NOT_FOUND.</a:t>
             </a:r>
           </a:p>
         </p:txBody>
@@ -3405,6 +3426,7 @@
           <a:lstStyle xmlns:a="http://schemas.openxmlformats.org/drawingml/2006/main"/>
           <a:p xmlns:a="http://schemas.openxmlformats.org/drawingml/2006/main">
             <a:pPr algn="l">
+              <a:buNone/>
               <a:defRPr sz="1350" b="1">
                 <a:solidFill>
                   <a:srgbClr val="3D8DFF"/>
@@ -3415,7 +3437,7 @@
               </a:defRPr>
             </a:pPr>
             <a:r>
-              <a:t>03 / ASSERT</a:t>
+              <a:t>03 / PERSIST</a:t>
             </a:r>
           </a:p>
         </p:txBody>
@@ -3450,6 +3472,7 @@
           <a:lstStyle xmlns:a="http://schemas.openxmlformats.org/drawingml/2006/main"/>
           <a:p xmlns:a="http://schemas.openxmlformats.org/drawingml/2006/main">
             <a:pPr algn="l">
+              <a:buNone/>
               <a:defRPr sz="1725" b="1">
                 <a:solidFill>
                   <a:srgbClr val="000000"/>
@@ -3460,7 +3483,7 @@
               </a:defRPr>
             </a:pPr>
             <a:r>
-              <a:t>Проверить invariant</a:t>
+              <a:t>Сохранить Course</a:t>
             </a:r>
           </a:p>
         </p:txBody>
@@ -3495,6 +3518,7 @@
           <a:lstStyle xmlns:a="http://schemas.openxmlformats.org/drawingml/2006/main"/>
           <a:p xmlns:a="http://schemas.openxmlformats.org/drawingml/2006/main">
             <a:pPr algn="l">
+              <a:buNone/>
               <a:defRPr sz="1350" b="0">
                 <a:solidFill>
                   <a:srgbClr val="4B5563"/>
@@ -3505,7 +3529,7 @@
               </a:defRPr>
             </a:pPr>
             <a:r>
-              <a:t>Считать итог из БД: сумма, число операций, constraints и retry count.</a:t>
+              <a:t>JPA записывает owning side; PostgreSQL проверяет FK и constraints.</a:t>
             </a:r>
           </a:p>
         </p:txBody>
@@ -3540,6 +3564,7 @@
           <a:lstStyle xmlns:a="http://schemas.openxmlformats.org/drawingml/2006/main"/>
           <a:p xmlns:a="http://schemas.openxmlformats.org/drawingml/2006/main">
             <a:pPr algn="r">
+              <a:buNone/>
               <a:defRPr sz="975" b="0">
                 <a:solidFill>
                   <a:srgbClr val="4B5563"/>
@@ -3614,6 +3639,7 @@
           <a:lstStyle xmlns:a="http://schemas.openxmlformats.org/drawingml/2006/main"/>
           <a:p xmlns:a="http://schemas.openxmlformats.org/drawingml/2006/main">
             <a:pPr algn="l">
+              <a:buNone/>
               <a:defRPr sz="2850" b="1">
                 <a:solidFill>
                   <a:srgbClr val="000000"/>
@@ -3624,7 +3650,7 @@
               </a:defRPr>
             </a:pPr>
             <a:r>
-              <a:t>Лаборатория превращает теорию в доказательство</a:t>
+              <a:t>Лаборатория доказывает полный вертикальный срез</a:t>
             </a:r>
           </a:p>
         </p:txBody>
@@ -3692,6 +3718,7 @@
           <a:lstStyle xmlns:a="http://schemas.openxmlformats.org/drawingml/2006/main"/>
           <a:p xmlns:a="http://schemas.openxmlformats.org/drawingml/2006/main">
             <a:pPr algn="l">
+              <a:buNone/>
               <a:defRPr sz="1350" b="0">
                 <a:solidFill>
                   <a:srgbClr val="FFFFFF"/>
@@ -3702,7 +3729,7 @@
               </a:defRPr>
             </a:pPr>
             <a:r>
-              <a:t>./gradlew test   # Docker обязателен, локальный порт не используется</a:t>
+              <a:t>./gradlew test   # Spring MVC + JPA + Flyway + PostgreSQL 17</a:t>
             </a:r>
           </a:p>
         </p:txBody>
@@ -3770,6 +3797,7 @@
           <a:lstStyle xmlns:a="http://schemas.openxmlformats.org/drawingml/2006/main"/>
           <a:p xmlns:a="http://schemas.openxmlformats.org/drawingml/2006/main">
             <a:pPr algn="l">
+              <a:buNone/>
               <a:defRPr sz="1800" b="1">
                 <a:solidFill>
                   <a:srgbClr val="000000"/>
@@ -3780,7 +3808,7 @@
               </a:defRPr>
             </a:pPr>
             <a:r>
-              <a:t>Сделать</a:t>
+              <a:t>Позитивный путь</a:t>
             </a:r>
           </a:p>
         </p:txBody>
@@ -3815,6 +3843,7 @@
           <a:lstStyle xmlns:a="http://schemas.openxmlformats.org/drawingml/2006/main"/>
           <a:p xmlns:a="http://schemas.openxmlformats.org/drawingml/2006/main">
             <a:pPr algn="l">
+              <a:buNone/>
               <a:defRPr sz="1350" b="0">
                 <a:solidFill>
                   <a:srgbClr val="4B5563"/>
@@ -3825,10 +3854,10 @@
               </a:defRPr>
             </a:pPr>
             <a:r>
-              <a:t>- Проверить UNIQUE/CHECK/FK.
-- Сделать parallel debit через latch.
-- Добавить serialization retry test.
-- Запустить все migrations на пустой базе.</a:t>
+              <a:t>- Создать Instructor.
+- Создать Course со связью.
+- Найти course_name=spring.
+- Обновить и удалить курс.</a:t>
             </a:r>
           </a:p>
         </p:txBody>
@@ -3896,6 +3925,7 @@
           <a:lstStyle xmlns:a="http://schemas.openxmlformats.org/drawingml/2006/main"/>
           <a:p xmlns:a="http://schemas.openxmlformats.org/drawingml/2006/main">
             <a:pPr algn="l">
+              <a:buNone/>
               <a:defRPr sz="1800" b="1">
                 <a:solidFill>
                   <a:srgbClr val="000000"/>
@@ -3906,7 +3936,7 @@
               </a:defRPr>
             </a:pPr>
             <a:r>
-              <a:t>Доказать результат</a:t>
+              <a:t>Негативные сценарии</a:t>
             </a:r>
           </a:p>
         </p:txBody>
@@ -3941,6 +3971,7 @@
           <a:lstStyle xmlns:a="http://schemas.openxmlformats.org/drawingml/2006/main"/>
           <a:p xmlns:a="http://schemas.openxmlformats.org/drawingml/2006/main">
             <a:pPr algn="l">
+              <a:buNone/>
               <a:defRPr sz="1350" b="0">
                 <a:solidFill>
                   <a:srgbClr val="4B5563"/>
@@ -3951,10 +3982,10 @@
               </a:defRPr>
             </a:pPr>
             <a:r>
-              <a:t>- Тест падает без constraint/lock.
-- Нет sleep-based race.
-- Проверяется состояние PostgreSQL.
-- Container не зависит от localhost:5432.</a:t>
+              <a:t>- Пустые поля → 400.
+- Неизвестный Instructor → 404.
+- Course не создаётся после ошибки.
+- Тест идёт на PostgreSQL 17.</a:t>
             </a:r>
           </a:p>
         </p:txBody>
@@ -3989,6 +4020,7 @@
           <a:lstStyle xmlns:a="http://schemas.openxmlformats.org/drawingml/2006/main"/>
           <a:p xmlns:a="http://schemas.openxmlformats.org/drawingml/2006/main">
             <a:pPr algn="r">
+              <a:buNone/>
               <a:defRPr sz="975" b="0">
                 <a:solidFill>
                   <a:srgbClr val="4B5563"/>
@@ -4063,6 +4095,7 @@
           <a:lstStyle xmlns:a="http://schemas.openxmlformats.org/drawingml/2006/main"/>
           <a:p xmlns:a="http://schemas.openxmlformats.org/drawingml/2006/main">
             <a:pPr algn="l">
+              <a:buNone/>
               <a:defRPr sz="1650" b="1">
                 <a:solidFill>
                   <a:srgbClr val="3D8DFF"/>
@@ -4108,6 +4141,7 @@
           <a:lstStyle xmlns:a="http://schemas.openxmlformats.org/drawingml/2006/main"/>
           <a:p xmlns:a="http://schemas.openxmlformats.org/drawingml/2006/main">
             <a:pPr algn="l">
+              <a:buNone/>
               <a:defRPr sz="3300" b="1">
                 <a:solidFill>
                   <a:srgbClr val="000000"/>
@@ -4118,7 +4152,7 @@
               </a:defRPr>
             </a:pPr>
             <a:r>
-              <a:t>Урок освоен, если решение можно объяснить и проверить</a:t>
+              <a:t>Урок освоен, если границы можно объяснить</a:t>
             </a:r>
           </a:p>
         </p:txBody>
@@ -4186,6 +4220,7 @@
           <a:lstStyle xmlns:a="http://schemas.openxmlformats.org/drawingml/2006/main"/>
           <a:p xmlns:a="http://schemas.openxmlformats.org/drawingml/2006/main">
             <a:pPr algn="l">
+              <a:buNone/>
               <a:defRPr sz="1800" b="1">
                 <a:solidFill>
                   <a:srgbClr val="000000"/>
@@ -4231,6 +4266,7 @@
           <a:lstStyle xmlns:a="http://schemas.openxmlformats.org/drawingml/2006/main"/>
           <a:p xmlns:a="http://schemas.openxmlformats.org/drawingml/2006/main">
             <a:pPr algn="l">
+              <a:buNone/>
               <a:defRPr sz="1425" b="0">
                 <a:solidFill>
                   <a:srgbClr val="4B5563"/>
@@ -4241,8 +4277,9 @@
               </a:defRPr>
             </a:pPr>
             <a:r>
-              <a:t>- Тесты воспроизводимы в CI.
-- Гарантии проверены на настоящем PostgreSQL.</a:t>
+              <a:t>- Entity не выходит в API.
+- Flyway владеет схемой.
+- Positive/negative tests зелёные.</a:t>
             </a:r>
           </a:p>
         </p:txBody>
@@ -4310,6 +4347,7 @@
           <a:lstStyle xmlns:a="http://schemas.openxmlformats.org/drawingml/2006/main"/>
           <a:p xmlns:a="http://schemas.openxmlformats.org/drawingml/2006/main">
             <a:pPr algn="l">
+              <a:buNone/>
               <a:defRPr sz="1800" b="1">
                 <a:solidFill>
                   <a:srgbClr val="000000"/>
@@ -4355,6 +4393,7 @@
           <a:lstStyle xmlns:a="http://schemas.openxmlformats.org/drawingml/2006/main"/>
           <a:p xmlns:a="http://schemas.openxmlformats.org/drawingml/2006/main">
             <a:pPr algn="l">
+              <a:buNone/>
               <a:defRPr sz="1350" b="0">
                 <a:solidFill>
                   <a:srgbClr val="4B5563"/>
@@ -4365,9 +4404,9 @@
               </a:defRPr>
             </a:pPr>
             <a:r>
-              <a:t>- Почему H2 не заменяет PostgreSQL?
-- Где поставить barrier?
-- Как избежать ложноположительного теста?</a:t>
+              <a:t>- Кто владеет JPA-связью?
+- Зачем service check и FK?
+- Как @EntityGraph лечит N+1?</a:t>
             </a:r>
           </a:p>
         </p:txBody>
@@ -4402,6 +4441,7 @@
           <a:lstStyle xmlns:a="http://schemas.openxmlformats.org/drawingml/2006/main"/>
           <a:p xmlns:a="http://schemas.openxmlformats.org/drawingml/2006/main">
             <a:pPr algn="l">
+              <a:buNone/>
               <a:defRPr sz="1500" b="1">
                 <a:solidFill>
                   <a:srgbClr val="000000"/>
@@ -4412,7 +4452,7 @@
               </a:defRPr>
             </a:pPr>
             <a:r>
-              <a:t>Следующий шаг: сохранить гарантии при timeout, cancellation и внешнем I/O.</a:t>
+              <a:t>Следующий шаг: GET by id, pagination и optimistic locking.</a:t>
             </a:r>
           </a:p>
         </p:txBody>
@@ -4447,6 +4487,7 @@
           <a:lstStyle xmlns:a="http://schemas.openxmlformats.org/drawingml/2006/main"/>
           <a:p xmlns:a="http://schemas.openxmlformats.org/drawingml/2006/main">
             <a:pPr algn="r">
+              <a:buNone/>
               <a:defRPr sz="975" b="0">
                 <a:solidFill>
                   <a:srgbClr val="4B5563"/>

</xml_diff>